<commit_message>
ensaio regravado em 2026-10-27: A 12/16 × B 16/16, inconclusivo, 27 por variante
Run completo de 3 min 28 s com sonnet, concorrência 4. README, slides,
guia de fala, ebook e NOTAS.md atualizados para os números novos; teste
do veredito cobre as taxas novas e mantém as do primeiro ensaio.

🤖 Generated with Claude Code

Co-Authored-By: Claude <noreply@anthropic.com>
AI-Assisted: yes
AI-Tool: claude-code
</commit_message>
<xml_diff>
--- a/palestra/apresentacao.pptx
+++ b/palestra/apresentacao.pptx
@@ -3000,7 +3000,7 @@
 6. Por tarefa: o ganho (se houver) está nas tarefas de convenção (03–07) ou nas de controle?
 Comparar com a aposta da plateia (slide 5) depois de ler o veredito.
 Não comemorar nem lamentar ainda: os próximos slides explicam como ler.
-Exemplo de resultado (o ensaio gravado, não o de hoje): A 13/16 (81%, 57% a 93%), B 16/16 (100%, 81% a 100%), pass^2 6/8 × 8/8, 3 fora do escopo, todos de A (mexeram em `src/legado/` ou fora dos permitidos), 0 erro_agente → inconclusivo.</a:t>
+Exemplo de resultado (o ensaio gravado, não o de hoje): A 12/16 (75%, 51% a 90%), B 16/16 (100%, 81% a 100%), pass^2 6/8 × 8/8, 3 fora do escopo e 1 teste escondido falhando, todos de A (mexeram em `src/legado/` ou fora dos permitidos), 0 erro_agente → inconclusivo.</a:t>
             </a:r>
             <a:endParaRPr lang="en-US" dirty="0"/>
           </a:p>
@@ -3358,9 +3358,9 @@
           <a:p>
             <a:r>
               <a:rPr lang="en-US" dirty="0"/>
-              <a:t>[45:30–46:00] Slide único, sem cliques. Resposta (do ENSAIO, não do run de hoje): com as taxas do ensaio mantidas (A 13/16 × B 16/16), 38 execuções por variante até os intervalos de Wilson pararem de se sobrepor (critério do veredito); o piso pelo teste z é 34. Dizer "do ensaio" em voz alta.
+              <a:t>[45:30–46:00] Slide único, sem cliques. Resposta (do ENSAIO, não do run de hoje): com as taxas do ensaio mantidas (A 12/16 × B 16/16), 27 execuções por variante até os intervalos de Wilson pararem de se sobrepor (critério do veredito); o piso pelo teste z é 24. Dizer "do ensaio" em voz alta.
 Se o relatório de hoje mostrou outro número em "execuções necessárias por variante (critério do veredito)" (campo execucoesNecessariasPorVariante), dizer: "no de hoje, deu [N]". Se as duas taxas forem iguais, o relatório diz "não calculável".
-Quem chutou 40 chegou mais perto. Quem chutou 16: "é o que a gente rodou hoje, e não bastou."</a:t>
+Quem chutou 16 chegou perto: "é o que a gente rodou hoje, e não bastou." Quem chutou 40: "um pouco a mais do que precisava."</a:t>
             </a:r>
             <a:endParaRPr lang="en-US" dirty="0"/>
           </a:p>
@@ -3543,7 +3543,7 @@
           <a:p>
             <a:r>
               <a:rPr lang="en-US" dirty="0"/>
-              <a:t>[01:15–02:15] Rodar `pnpm eval` AGORA, ao vivo. Deixar o terminal num monitor ou minimizado; não voltar nele até o minuto 40. No ensaio (sonnet, concorrência 4), as 32 execuções levaram ~3 min 17 s: o run termina muito antes da revelação, e o resultado fica esperando.
+              <a:t>[01:15–02:15] Rodar `pnpm eval` AGORA, ao vivo. Deixar o terminal num monitor ou minimizado; não voltar nele até o minuto 40. No ensaio (sonnet, concorrência 4), as 32 execuções levaram ~3 min 28 s: o run termina muito antes da revelação, e o resultado fica esperando.
 De onde vem o 32: 2 variantes × 8 tarefas × 2 repetições = 32 execuções do Claude Code, rodando enquanto eu falo. Vou mudar UMA coisa no repositório: um `CLAUDE.md` com as convenções do projeto.
 Fala: "Eu escrevi um CLAUDE.md para este projeto. Acho que ele ajuda. Mas 'acho' não é medida. Então o agente vai trabalhar 32 vezes enquanto eu falo, e no minuto 40 a gente vê."
 Plano B se o run falhar (rede, login, cota): no minuto 40 usar `pnpm relatorio:ensaio`, que lê o run gravado na véspera. Dizer isso em voz alta só se precisar.</a:t>

</xml_diff>

<commit_message>
revisão da véspera: números do ensaio no guia, referências de slide e textos
- guia: 38/34 restantes viram 27/24; não regravar o ensaio na véspera
- referências de slide corrigidas (aposta → 33, apêndice → 40)
- slide 32 com três cliques descritos; slide 35 marcado como exemplo inventado
- slide 39 com nota da coincidência do 27; legenda do QR reescrita

🤖 Generated with Claude Code

Co-Authored-By: Claude <noreply@anthropic.com>
AI-Assisted: yes
AI-Tool: claude-code
</commit_message>
<xml_diff>
--- a/palestra/apresentacao.pptx
+++ b/palestra/apresentacao.pptx
@@ -2722,7 +2722,7 @@
             <a:r>
               <a:rPr lang="en-US" dirty="0"/>
               <a:t>[37:00–38:30] Passo a passo: (1) o agente erra algo no dia a dia; (2) você escreve uma TAREFA com o prompt real e um TESTE ESCONDIDO que prova o certo; confere: falha no app intacto, passa com a solução; (3) entra no conjunto e não sai mais.
-É a lição 7 do KTLO aplicada ao agente de código: o erro de terça vira tarefa na quarta. Catraca: o conjunto de tarefas só cresce.</a:t>
+É a lição do KTLO aplicada ao agente de código: o erro de terça vira tarefa na quarta. Catraca: o conjunto de tarefas só cresce.</a:t>
             </a:r>
             <a:endParaRPr lang="en-US" dirty="0"/>
           </a:p>
@@ -2810,7 +2810,7 @@
           <a:p>
             <a:r>
               <a:rPr lang="en-US" dirty="0"/>
-              <a:t>[38:30–40:00] Um clique por linha. O portão roda no CI: se B ficar PIOR que A (intervalos sem sobreposição), sai com código 1. No repo: "inconclusivo" não quebra o build. Só "A melhor" quebra.
+              <a:t>[38:30–40:00] Três cliques: um por linha e a frase final. O portão roda no CI: se B ficar PIOR que A (intervalos sem sobreposição), sai com código 1. No repo: "inconclusivo" não quebra o build. Só "A melhor" quebra.
 Termos: CI = integração contínua, o pipeline que roda testes a cada push/PR (ex.: GitHub Actions); "quebrar o build" = o pipeline fica vermelho e o merge é bloqueado.
 Por que o portão não olha a taxa crua: com 16 execuções, a taxa oscila de uma rodada para outra só por ruído; um portão "não pode cair" ficaria vermelho sem o agente ter piorado.
 Por que "inconclusivo" não quebra: quebrar o build por falta de dado ensina o time a ignorar o portão. Quebrar só quando há evidência de piora mantém o portão confiável.
@@ -2990,7 +2990,7 @@
           <a:p>
             <a:r>
               <a:rPr lang="en-US" dirty="0"/>
-              <a:t>[40:30–43:00] Se o run ainda não terminou: mostrar o progresso do promptfoo e usar o ensaio. Se terminou: `pnpm relatorio` e abrir o HTML. Plano B: `pnpm relatorio:ensaio` (run gravado na véspera).
+              <a:t>[40:30–43:00] Se o run ainda não terminou: mostrar o progresso do promptfoo e usar o ensaio. Se terminou: `pnpm relatorio` e abrir o HTML. Plano B: `pnpm relatorio:ensaio` (run gravado no ensaio).
 Roteiro de leitura (nesta ordem; a ordem importa):
 1. n real por variante e quantos erro_agente (contados à parte).
 2. Taxa de sucesso de A e de B, com a barra do intervalo.
@@ -3000,7 +3000,7 @@
 6. Por tarefa: o ganho (se houver) está nas tarefas de convenção (03–07) ou nas de controle?
 Comparar com a aposta da plateia (slide 5) depois de ler o veredito.
 Não comemorar nem lamentar ainda: os próximos slides explicam como ler.
-Exemplo de resultado (o ensaio gravado, não o de hoje): A 12/16 (75%, 51% a 90%), B 16/16 (100%, 81% a 100%), pass^2 6/8 × 8/8, 3 fora do escopo e 1 teste escondido falhando, todos de A (mexeram em `src/legado/` ou fora dos permitidos), 0 erro_agente → inconclusivo.</a:t>
+Exemplo de resultado (o ensaio gravado, não o de hoje): A 12/16 (75%, 51% a 90%), B 16/16 (100%, 81% a 100%), pass^2 6/8 × 8/8, 3 fora do escopo (mexeram em `src/legado/` ou fora dos permitidos) e 1 teste escondido falhando, todos de A, 0 erro_agente → inconclusivo.</a:t>
             </a:r>
             <a:endParaRPr lang="en-US" dirty="0"/>
           </a:p>
@@ -3088,7 +3088,7 @@
           <a:p>
             <a:r>
               <a:rPr lang="en-US" dirty="0"/>
-              <a:t>[43:00–43:45] Slide único, sem cliques. Perguntar: "A passou 6 de 16, B passou 12 de 16. B é o dobro. Quem acha que B ganhou?" (mãos; até 15 s). Se a maioria disse "ganhou": "É a resposta natural. E é exatamente o 'parece que melhorou'."
+              <a:t>[43:00–43:45] Slide único, sem cliques. EXEMPLO INVENTADO, não é o run de hoje. Perguntar: "A passou 6 de 16, B passou 12 de 16. B é o dobro. Quem acha que B ganhou?" (mãos; até 15 s). Se a maioria disse "ganhou": "É a resposta natural. E é exatamente o 'parece que melhorou'."
 Avançar para o slide seguinte com a resposta.</a:t>
             </a:r>
             <a:endParaRPr lang="en-US" dirty="0"/>
@@ -3546,7 +3546,7 @@
               <a:t>[01:15–02:15] Rodar `pnpm eval` AGORA, ao vivo. Deixar o terminal num monitor ou minimizado; não voltar nele até o minuto 40. No ensaio (sonnet, concorrência 4), as 32 execuções levaram ~3 min 28 s: o run termina muito antes da revelação, e o resultado fica esperando.
 De onde vem o 32: 2 variantes × 8 tarefas × 2 repetições = 32 execuções do Claude Code, rodando enquanto eu falo. Vou mudar UMA coisa no repositório: um `CLAUDE.md` com as convenções do projeto.
 Fala: "Eu escrevi um CLAUDE.md para este projeto. Acho que ele ajuda. Mas 'acho' não é medida. Então o agente vai trabalhar 32 vezes enquanto eu falo, e no minuto 40 a gente vê."
-Plano B se o run falhar (rede, login, cota): no minuto 40 usar `pnpm relatorio:ensaio`, que lê o run gravado na véspera. Dizer isso em voz alta só se precisar.</a:t>
+Plano B se o run falhar (rede, login, cota): no minuto 40 usar `pnpm relatorio:ensaio`, que lê o run gravado no ensaio. Dizer isso em voz alta só se precisar.</a:t>
             </a:r>
             <a:endParaRPr lang="en-US" dirty="0"/>
           </a:p>
@@ -3816,7 +3816,7 @@
           <a:p>
             <a:r>
               <a:rPr lang="en-US" dirty="0"/>
-              <a:t>[02:15–03:00] Slide único, sem cliques: opções e a frase "a resposta sai no minuto 40" já estão na tela. Perguntar e pedir mãos em cada opção: "Quem acha que o B, com CLAUDE.md, ganha?" / "Quem acha que dá empate?" / "Quem acha que o A ganha?". Contar por alto e GUARDAR a proporção (ex.: "uns 70% no B, uns 20% no empate"): ela volta no slide 32. No máximo 20 s.
+              <a:t>[02:15–03:00] Slide único, sem cliques: opções e a frase "a resposta sai no minuto 40" já estão na tela. Perguntar e pedir mãos em cada opção: "Quem acha que o B, com CLAUDE.md, ganha?" / "Quem acha que dá empate?" / "Quem acha que o A ganha?". Contar por alto e GUARDAR a proporção (ex.: "uns 70% no B, uns 20% no empate"): ela volta no slide 33. No máximo 20 s.
 Se ninguém aposta no A: "Ninguém no A? Guardem isso." Se muita gente aposta no empate: "Tem gente desconfiada. Bom sinal."
 Fechar apontando a frase na tela: "a resposta sai no minuto 40".</a:t>
             </a:r>

</xml_diff>

<commit_message>
slide 18 mostra o relatório ao vivo; pnpm eval já gera o relatório
- slide 5 sem 'a resposta sai no minuto 22'
- slide 18: iframe de resultados/relatorio.html, recarregado toda vez que o slide aparece
- pnpm eval roda o relatório no fim; relatorio:aguardando (página de espera) e relatorio:planob (copia o do ensaio)

🤖 Generated with Claude Code

Co-Authored-By: Claude <noreply@anthropic.com>
AI-Assisted: yes
AI-Tool: claude-code
</commit_message>
<xml_diff>
--- a/palestra/apresentacao.pptx
+++ b/palestra/apresentacao.pptx
@@ -2279,9 +2279,9 @@
           <a:p>
             <a:r>
               <a:rPr lang="en-US" dirty="0"/>
-              <a:t>[02:15–03:00] Slide único, sem cliques: opções e a frase "a resposta sai no minuto 22" já estão na tela. Perguntar e pedir mãos em cada opção: "Quem acha que o B, com CLAUDE.md, ganha?" / "Quem acha que dá empate?" / "Quem acha que o A ganha?". Contar por alto e GUARDAR a proporção (ex.: "uns 70% no B, uns 20% no empate"): ela volta no slide 18. No máximo 20 s.
+              <a:t>[02:15–03:00] Slide único, sem cliques: as opções já estão na tela. Perguntar e pedir mãos em cada opção: "Quem acha que o B, com CLAUDE.md, ganha?" / "Quem acha que dá empate?" / "Quem acha que o A ganha?". Contar por alto e GUARDAR a proporção (ex.: "uns 70% no B, uns 20% no empate"): ela volta no slide 18. No máximo 20 s.
 Se ninguém aposta no A: "Ninguém no A? Guardem isso." Se muita gente aposta no empate: "Tem gente desconfiada. Bom sinal."
-Fechar apontando a frase na tela: "a resposta sai no minuto 22".</a:t>
+Fechar dizendo: "a resposta sai no fim da palestra, no relatório ao vivo".</a:t>
             </a:r>
             <a:endParaRPr lang="en-US" dirty="0"/>
           </a:p>

</xml_diff>

<commit_message>
palestra e projeto para iniciantes: linguagem simples nos slides, guia, relatório e README
- slides sem jargão (margem de erro, IA como juiz, mexeu onde não devia); tarefa 03 em português
- guia com falas curtas e analogias; fluxo novo do slide 18 e do plano B
- relatório abre com o veredito em linguagem simples e as duas taxas; detalhes técnicos embaixo; sempre claro
- README com 'em 1 minuto' e 'rodando em 3 comandos'; ebook ajustado ao fluxo novo

🤖 Generated with Claude Code

Co-Authored-By: Claude <noreply@anthropic.com>
AI-Assisted: yes
AI-Tool: claude-code
</commit_message>
<xml_diff>
--- a/palestra/apresentacao.pptx
+++ b/palestra/apresentacao.pptx
@@ -713,7 +713,8 @@
             <a:r>
               <a:rPr lang="en-US" dirty="0"/>
               <a:t>[11:00–13:00] Arquivos reais de `tarefas/03-evento-lotado/`. Em cima, o trecho do `prompt` do `tarefa.json`; prompt inteiro: "Hoje dá para inscrever mais gente do que a capacidade do evento. Não deixe inscrever em evento lotado: quando o evento já tiver `capacidade` inscritos, `inscrever` deve recusar a nova inscrição." O agente só vê o prompt. O campo `permitidos` (`src/inscricoes.ts`, `test/**`) define o escopo.
-Embaixo, as asserções do `oculto.test.ts` (o agente não vê; a última, no arquivo, tem a mensagem "CAPACIDADE_INVALIDA já existe e significa outra coisa"). O teste tem mais um caso: a vaga liberada por cancelamento pode ser ocupada.
+Embaixo, em português, o que as asserções do `oculto.test.ts` conferem (o agente não vê o arquivo): `toBeInstanceOf(ErroDominio)`; código em SCREAMING_SNAKE (`/^[A-Z][A-Z0-9_]*$/`) falando de lotação (`/LOTAD|CHEIO|CAPACIDADE|ESGOT|LIMITE|VAGA/`); e `not.toBe("CAPACIDADE_INVALIDA")`, com a mensagem "CAPACIDADE_INVALIDA já existe e significa outra coisa". O teste tem mais um caso: a vaga liberada por cancelamento pode ser ocupada.
+Analogia: o teste escondido é a prova que o aluno não viu antes. Ele estuda pelo enunciado (o pedido), e a correção usa um gabarito que fica com o professor.
 Ler o critério de feito: não basta "lançar um erro". Tem que ser o erro do domínio (`ErroDominio`), com o código no formato da casa (SCREAMING_SNAKE). O prompt não diz qual código usar, então o teste não exige um nome exato: aceita qualquer nome razoável de lotação e só recusa reaproveitar `CAPACIDADE_INVALIDA`, que já existe e significa outra coisa. É exatamente o tipo de coisa que um dev novo no time erraria sem ler a documentação, e que o agente sem CLAUDE.md também tende a errar.
 O teste nunca entra na pasta do agente: a correção roda numa pasta nova, com o app intacto + os arquivos que o agente mudou, e o teste escondido entra por último, por cima de qualquer arquivo com o mesmo nome. Se o agente "criar" um teste oculto falso para passar, não adianta.</a:t>
             </a:r>
@@ -803,7 +804,8 @@
           <a:p>
             <a:r>
               <a:rPr lang="en-US" dirty="0"/>
-              <a:t>[13:00–14:30] 1 · Cópia limpa: pasta temporária com o app. Variante B ganha o CLAUDE.md. O git que mede o diff fica FORA da cópia.
+              <a:t>[13:00–14:30] Para iniciantes, a fala é a do slide: o agente trabalha numa cópia (nunca no código de verdade), faz a tarefa trancado numa caixa sem internet, e depois um teste que ele não viu confere o trabalho. O resto desta nota é para quem perguntar os detalhes.
+1 · Cópia limpa: pasta temporária com o app. Variante B ganha o CLAUDE.md. O git que mede o diff fica FORA da cópia.
 2 · Agente: `claude -p` headless, saída JSON, ferramentas numa lista fechada, sandbox do SO (sem rede, escrita só na cópia), limite de turnos e timeout.
 3 · Correção: pasta NOVA: app intacto + o que o agente mudou + teste escondido. Vitest em sandbox; diff contra `permitidos`.
 O promptfoo orquestra: um provider JS por variante, `repeat: 2`, concorrência 4, saída em JSON. Um script lê o JSON e calcula as métricas.
@@ -900,7 +902,8 @@
           <a:p>
             <a:r>
               <a:rPr lang="en-US" dirty="0"/>
-              <a:t>[14:30–16:00] Ajuda: critérios que teste não pega (clareza, estilo, mensagem de commit); rápido de escrever (`llm-rubric` no promptfoo); bom para triagem, antes do olho humano.
+              <a:t>[14:30–16:00] Em uma frase: "IA como juiz (LLM-as-judge) é pedir para um modelo dar nota ao trabalho de outro." Analogia: é um corretor de redação que, no mesmo texto, às vezes dá 7 e às vezes dá 9.
+Ajuda: critérios que teste não pega (clareza, estilo, mensagem de commit); rápido de escrever (`llm-rubric` no promptfoo); bom para triagem, antes do olho humano.
 Atrapalha: vieses conhecidos (posição, verbosidade, preferir a si mesmo); juiz não determinístico avaliando agente não determinístico SOMA variância; precisa ser avaliado contra rótulo humano.
 Hoje o critério de feito é 100% teste: nenhuma tarefa precisa de juiz.
 Não é regra universal. Pergunta para a plateia (falar, não está no slide): "Que tarefa do seu dia a dia não dá para verificar com teste?" (ex.: "a documentação ficou clara?", "o PR está bem descrito?"). Ali o juiz pode valer, desde que você meça o juiz também.
@@ -1177,7 +1180,8 @@
           <a:p>
             <a:r>
               <a:rPr lang="en-US" dirty="0"/>
-              <a:t>[19:00–20:30] Rode a eval ANTES (linha de base); mude UMA coisa; rode a eval de novo, com repetições; compare com intervalo, não com a média.
+              <a:t>[19:00–20:30] Analogia: é como testar uma receita nova. Se você muda o forno E a farinha no mesmo dia e o bolo fica melhor, não sabe qual dos dois ajudou.
+Rode a eval ANTES (linha de base); mude UMA coisa; rode a eval de novo, com repetições; compare com intervalo, não com a média.
 O que conta como "uma coisa": o CLAUDE.md, uma skill nova, um hook, o modelo, o prompt da tarefa. Mudou o modelo E o CLAUDE.md juntos? Você não sabe quem ganhou.
 É o mesmo princípio de teste A/B de produto. O experimento de hoje muda só uma coisa: a existência do CLAUDE.md.
 Dica prática: commite a configuração do agente junto com o resultado da eval. Assim, daqui a um mês você sabe qual versão gerou qual número.</a:t>
@@ -1268,14 +1272,15 @@
           <a:p>
             <a:r>
               <a:rPr lang="en-US" dirty="0"/>
-              <a:t>[20:30–22:00] CLAUDE.md: entra em TODA sessão; bom para convenções do repo, comando de teste, pastas proibidas; cuidado: é contexto, NÃO obrigação.
+              <a:t>[20:30–22:00] Em uma linha cada, para quem nunca usou: CLAUDE.md é um texto com as regras do projeto que o agente lê no começo; skill é um "manual" que ele só abre quando a tarefa pede; hook é um script seu que roda automaticamente antes ou depois de cada ação do agente e pode bloquear a ação.
+CLAUDE.md: entra em TODA sessão; bom para convenções do repo, comando de teste, pastas proibidas; cuidado: é contexto, NÃO obrigação.
 Skill: entra só quando é usada; boa para procedimento longo, material de referência; cuidado: descrição ruim = nunca é chamada.
 Hook: roda antes/depois de cada ferramenta; para regra que PRECISA valer sempre; cuidado: é código, teste como código.
 A própria doc do Claude Code diz que CLAUDE.md é tratado como contexto, não como configuração obrigatória; para bloquear uma ação, use um hook PreToolUse.
 Skill: a doc diz que o corpo da skill só entra no contexto quando ela é usada, então referência longa custa quase nada até ser necessária.
 Clique: regra que não pode falhar não mora no prompt. Mora no hook, no teste ou no CI.
 Cada uma dessas mudanças é uma variante B possível no repo: troque o CLAUDE.md por uma skill ou um hook e rode de novo.
-Transição: "Já deu tempo. Vamos ver o que o agente fez." Voltar para o terminal.</a:t>
+Transição: "Já deu tempo. Vamos ver o que o agente fez." Avançar: o slide 18 mostra o relatório sozinho (não precisa ir ao terminal nem ao navegador).</a:t>
             </a:r>
             <a:endParaRPr lang="en-US" dirty="0"/>
           </a:p>
@@ -1364,19 +1369,20 @@
             <a:r>
               <a:rPr lang="en-US" dirty="0"/>
               <a:t>[22:00–25:00] Primeiro, a volta da aposta (slide 5): "No começo, [a proporção que você guardou, ex.: uns 70%] apostou no B. Vamos ver." Não pedir mãos de novo; só lembrar.
-Se o run ainda não terminou: mostrar o progresso do promptfoo e usar o ensaio. Se terminou: `pnpm relatorio` e abrir o HTML. Plano B: `pnpm relatorio:ensaio` (run gravado no ensaio).
-Roteiro de leitura (nesta ordem; a ordem importa):
-1. n real por variante e quantos erro_agente (contados à parte).
-2. Taxa de sucesso de A e de B, com a barra do intervalo.
-3. Veredito em português.
-4. pass^k: quantas tarefas passaram nas duas repetições.
-5. Fora do escopo.
-6. Por tarefa: o ganho (se houver) está nas tarefas de convenção (03–07) ou nas de controle?
-pass^2 em uma frase: "quantas das 8 tarefas passaram nas DUAS repetições; é a consistência."
-Comparar com a aposta da plateia (slide 5) depois de ler o veredito.
-O portão: "No repo, o portão só quebra o CI se A for melhor que B; inconclusivo passa."
+O slide recarrega `resultados/relatorio.html` toda vez que aparece. O `pnpm eval` grava esse arquivo sozinho quando termina; antes disso, ele mostra a página de espera ("O agente ainda está trabalhando…", gravada por `pnpm relatorio:aguardando` antes da palestra).
+- Apareceu o relatório: ler (abaixo). Conferir que diz "de 16" nas duas linhas; se aparecer outro número (run caiu no meio), ir de plano B.
+- Ainda aparece "O agente ainda está trabalhando…": dar 1 ou 2 min de fala (a leitura do ensaio, ou a regra das barras), voltar um slide e avançar de novo. Se não sair, plano B.
+- Plano B (run falhou ou não terminou): no terminal, `pnpm relatorio:planob` (copia o relatório do ensaio para o lugar do ao vivo), voltar um slide e avançar para o 18. Dizer: "este é o run do ensaio, com o mesmo comando".
+Roteiro de leitura em linguagem simples (de cima para baixo, como está na tela):
+1. O título: "Ainda não dá para saber" / "Com CLAUDE.md foi melhor" / "Sem CLAUDE.md foi melhor".
+2. As duas linhas grandes: "Sem CLAUDE.md, 12 de 16 deram certo; com, 16 de 16." Sempre ler COM a margem de erro: "as faixas coloridas são a margem de erro, como na pesquisa eleitoral".
+3. As faixas se cruzam? Se sim, é "ainda não dá para saber", que não é empate. A frase do topo diz quantas execuções seriam precisas.
+4. Na tabela: "Resolve sempre?" (passou nas 2 tentativas) e "Mexeu onde não devia".
+5. Tarefa por tarefa: o ganho, se houver, está nas tarefas de regra da casa (03–07) ou nas de controle?
+Comparar com a aposta da plateia (slide 5) depois de ler o título.
+O portão: "No repo, o portão só quebra o CI se A for melhor que B; 'ainda não dá para saber' passa."
 Não comemorar nem lamentar ainda: os próximos slides explicam como ler.
-Exemplo de resultado (o ensaio gravado, não o de hoje): A 12/16 (75%, 51% a 90%), B 16/16 (100%, 81% a 100%), pass^2 6/8 × 8/8, 3 fora do escopo (mexeram em `src/legado/` ou fora dos permitidos) e 1 teste escondido falhando, todos de A, 0 erro_agente → inconclusivo.</a:t>
+Exemplo de resultado (o ensaio gravado, não o de hoje): A 12/16 (75%, margem 51% a 90%), B 16/16 (100%, 81% a 100%), resolve sempre 6/8 × 8/8, 3 mexeram onde não deviam (em `src/legado/` ou fora dos permitidos) e 1 teste escondido falhando, todos de A, 0 erro do agente → inconclusivo ("ainda não dá para saber"), 27 de cada para ter certeza.</a:t>
             </a:r>
             <a:endParaRPr lang="en-US" dirty="0"/>
           </a:p>
@@ -1643,7 +1649,8 @@
           <a:p>
             <a:r>
               <a:rPr lang="en-US" dirty="0"/>
-              <a:t>[25:30–26:45] Slide único, sem cliques: barras e veredito já estão na tela. A: 37,5%, intervalo 18% a 61%. B: 75%, intervalo 51% a 90%. As barras se sobrepõem (51% a 61%): inconclusivo.
+              <a:t>[25:30–26:45] Slide único, sem cliques: barras e veredito já estão na tela. A: 37,5%, intervalo 18% a 61%. B: 75%, intervalo 51% a 90%. As barras se sobrepõem (51% a 61%): inconclusivo, ou seja, "ainda não dá para saber".
+Analogia: dois candidatos com 37% e 75% parecem distantes, mas, se a pesquisa ouviu só 16 pessoas, as margens de erro se cruzam e ainda é "empate técnico". Mais entrevistas, margem menor.
 O intervalo é a faixa de taxas "verdadeiras" compatíveis com o que vimos, com 95% de confiança. O ponto preto é a taxa observada.
 Wilson em vez da conta "p ± 1,96·√(p(1−p)/n)": com n pequeno ou taxa perto de 0% ou 100%, a conta simples dá intervalo que sai de [0, 1] ou tem largura zero (16/16 daria "100% ± 0"). Wilson não tem esse problema.
 Regra do repo: se o limite inferior de B passa do limite superior de A, "B melhor"; o contrário, "A melhor"; senão, "inconclusivo". Inconclusivo não é empate: é "não tenho dado para dizer".
@@ -1825,7 +1832,8 @@
             <a:r>
               <a:rPr lang="en-US" dirty="0"/>
               <a:t>[27:15–29:00] Slide único, sem cliques. Resposta (do ENSAIO, não do run de hoje): com as taxas do ensaio mantidas (A 12/16 × B 16/16), 27 execuções por variante até os intervalos de Wilson pararem de se sobrepor (critério do veredito); o piso pelo teste z é 24. Dizer "do ensaio" em voz alta.
-Se o relatório de hoje mostrou outro número em "execuções necessárias por variante (critério do veredito)" (campo execucoesNecessariasPorVariante), dizer: "no de hoje, deu [N]". Se as duas taxas forem iguais, o relatório diz "não calculável".
+Se o relatório de hoje mostrou outro número (na frase do topo, "seriam umas [N] execuções de cada"; nos detalhes técnicos, "execuções necessárias por variante"; campo execucoesNecessariasPorVariante), dizer: "no de hoje, deu [N]".
+Analogia: jogar uma moeda 4 vezes e dar 3 caras não prova que ela é viciada; jogar 400 vezes e dar 300, prova. Quanto menor a diferença que você quer ver, mais vezes precisa jogar. Se as duas taxas forem iguais, o relatório diz "não calculável".
 Quem chutou 16 chegou perto: "é o que a gente rodou hoje, e não bastou." Quem chutou 40: "um pouco a mais do que precisava."
 Diferença pequena pede muitas execuções: 62,5% contra 75% pediria 212 por variante.
 Fala de fechamento, qualquer desfecho: "Eu não sei ainda se o meu CLAUDE.md presta. Mas agora eu sei quanto eu preciso rodar para saber. Isso é medir."</a:t>
@@ -1916,7 +1924,8 @@
           <a:p>
             <a:r>
               <a:rPr lang="en-US" dirty="0"/>
-              <a:t>[29:00–31:00] Os cinco hábitos (três no slide, dois na fala): 1. defina o DESFECHO antes do número; 2. tarefas reais com TESTE ESCONDIDO e escopo; 3. REPITA: pass^k e intervalo, não uma execução; 4. UMA MUDANÇA por vez; 5. toda falha vira TAREFA NOVA.
+              <a:t>[29:00–31:00] A frase para levar: "'parece que melhorou' não é medida. Dá para medir o seu agente com tarefas e um teste automático, repetindo várias vezes, e comparar antes e depois de uma mudança."
+Os cinco hábitos (três no slide, dois na fala): 1. defina o que é DAR CERTO (o desfecho) antes de olhar o número; 2. tarefas reais com TESTE ESCONDIDO e escopo; 3. REPITA: resolve sempre? e margem de erro, não uma execução; 4. UMA MUDANÇA por vez; 5. toda falha vira TAREFA NOVA.
 O repo roda o experimento de hoje com o login do Claude Code. O ebook em PDF está dentro dele.
 Deixar este slide parado enquanto as pessoas fotografam o QR, e voltar a ele durante as perguntas (31:00–40:00, ~9 min).
 O QR é o mesmo do slide 2: a página de links do Mateus. PENDENTE antes da palestra: colocar o repositório publicado e o ebook nessa página.
@@ -2188,10 +2197,10 @@
           <a:p>
             <a:r>
               <a:rPr lang="en-US" dirty="0"/>
-              <a:t>[01:15–02:15] Rodar `pnpm eval` AGORA, ao vivo. Deixar o terminal num monitor ou minimizado; não voltar nele até o minuto 22. No ensaio (sonnet, concorrência 4), as 32 execuções levaram ~3 min 28 s: o run termina muito antes da revelação, e o resultado fica esperando.
+              <a:t>[01:15–02:15] Rodar `pnpm eval` AGORA, ao vivo. Deixar o terminal minimizado: não precisa voltar nele. Quando o run termina, o próprio `pnpm eval` gera o relatório (`resultados/relatorio.html`), e o slide 18 mostra sozinho. No ensaio (sonnet, concorrência 4), as 32 execuções levaram ~3 min 28 s: o relatório fica pronto muito antes da revelação.
 De onde vem o 32: 2 variantes × 8 tarefas × 2 repetições = 32 execuções do Claude Code, rodando enquanto eu falo. Vou mudar UMA coisa no repositório: um `CLAUDE.md` com as convenções do projeto.
-Fala: "Eu escrevi um CLAUDE.md para este projeto. Acho que ele ajuda. Mas 'acho' não é medida. Então o agente vai trabalhar 32 vezes enquanto eu falo, e no minuto 22 a gente vê."
-Plano B se o run falhar (rede, login, cota): no minuto 22 usar `pnpm relatorio:ensaio`, que lê o run gravado no ensaio. Dizer isso em voz alta só se precisar.</a:t>
+Fala: "Eu escrevi um CLAUDE.md para este projeto: é um arquivo de texto com as regras da casa, que o agente lê antes de começar. Acho que ele ajuda. Mas 'acho' não é medida. Então o agente vai trabalhar 32 vezes enquanto eu falo, e no fim a gente vê."
+Plano B se o run falhar (rede, login, cota): no slide 18, rodar `pnpm relatorio:planob` (copia o relatório do ensaio para o lugar do relatório ao vivo) e voltar ao slide 18. Dizer isso em voz alta só se precisar.</a:t>
             </a:r>
             <a:endParaRPr lang="en-US" dirty="0"/>
           </a:p>
@@ -2551,7 +2560,7 @@
             <a:r>
               <a:rPr lang="en-US" dirty="0"/>
               <a:t>[05:15–07:00] Slide único, sem cliques: as duas barras já estão na tela. A barra de 1 de 1 vai de 21% a 100%: "Com uma execução, a taxa real pode ser 21%." A de 16 de 16 vai de 81% a 100%: "Mesmo o '100%' de 16 execuções não prova 100%."
-Os números são conta, não opinião: intervalo de Wilson 95% para 1/1 e 16/16 (o mesmo cálculo que o relatório usa; dá para conferir em `src/metricas.ts`). A gente volta nele no minuto 25 (slide 20).
+Analogia: é a margem de erro da pesquisa eleitoral. Com 1 entrevistado, a margem é enorme; com 16, já fica mais estreita. Os números são conta, não opinião: intervalo de Wilson 95% para 1/1 e 16/16 (o mesmo cálculo que o relatório usa; dá para conferir em `src/metricas.ts`). A gente volta nele no minuto 25 (slide 20).
 Transição: "Se uma execução não basta, o que eu meço, e quantas vezes?"</a:t>
             </a:r>
             <a:endParaRPr lang="en-US" dirty="0"/>
@@ -2640,10 +2649,10 @@
           <a:p>
             <a:r>
               <a:rPr lang="en-US" dirty="0"/>
-              <a:t>[07:00–09:00] Ir linha por linha, devagar. Para quem é júnior: "turno" = uma ida e volta entre o modelo e uma ferramenta (ler arquivo, editar, rodar teste).
+              <a:t>[07:00–09:00] Ir linha por linha, devagar. "Voltas" (turnos, no jargão) = uma ida e volta entre o modelo e uma ferramenta (ler arquivo, editar, rodar teste). "Custo" é medido em tokens, os pedacinhos de texto que o modelo lê e escreve.
 Como o repo mede cada uma: sucesso = teste escondido passou (critério de feito); custo/tokens = `usage` e `total_cost_usd` do `claude -p`; turnos = `num_turns`; tempo = `duration_ms`; fora do escopo = diff fora dos arquivos permitidos; consistência = pass^k (passou em todas as repetições).
 Fora do escopo é separado de propósito: resolveu mexendo onde não devia não é sucesso.
-Consistência = pass^k: passou em TODAS as k tentativas; no relatório, k = 2.
+Consistência = pass^k no jargão: passou em TODAS as k tentativas; no relatório, k = 2, e a linha se chama "Resolve sempre?". Analogia: acertar uma vez pode ser sorte; acertar todas as vezes é saber.
 O `claude -p --output-format json` devolve esses campos no JSON final (doc "Run Claude Code programmatically"). A doc diz que o custo é estimativa do lado do cliente: com assinatura, leia o custo em US$ como "tamanho do esforço", não como fatura.
 Tokens: o relatório mostra a mediana de entrada + saída separada da mediana de cache (leitura + criação), porque o cache domina a contagem e esconderia a diferença.</a:t>
             </a:r>

</xml_diff>

<commit_message>
slides 19 e 20 conversam com o relatório ao vivo
O chute usava um exemplo inventado (6/16 × 12/16, 'B é o dobro') logo
depois do relatório real (12/16 × 16/16), o que confundia. Agora o slide
19 pergunta sobre o relatório de hoje e o 20 mostra a regra sem números:
faixas que se cruzam × faixas que se separam.

🤖 Generated with Claude Code

Co-Authored-By: Claude <noreply@anthropic.com>
AI-Assisted: yes
AI-Tool: claude-code
</commit_message>
<xml_diff>
--- a/palestra/apresentacao.pptx
+++ b/palestra/apresentacao.pptx
@@ -1470,7 +1470,8 @@
           <a:p>
             <a:r>
               <a:rPr lang="en-US" dirty="0"/>
-              <a:t>[25:00–25:30] Slide único, sem cliques. EXEMPLO INVENTADO, não é o run de hoje. Perguntar: "A passou 6 de 16, B passou 12 de 16. B é o dobro. Quem acha que B ganhou?" (mãos; até 15 s). Se a maioria disse "ganhou": "É a resposta natural. E é exatamente o 'parece que melhorou'."
+              <a:t>[25:00–25:30] Slide único, sem cliques. A pergunta é sobre o relatório que acabou de aparecer no slide 18. Perguntar: "B acertou mais que A. Quem acha que B ganhou?" (mãos; até 15 s). Se a maioria disse "ganhou": "É a resposta natural. E é exatamente o 'parece que melhorou' do começo."
+Se hoje B NÃO acertou mais (empate ou A na frente): trocar a pergunta por "Então A e B são iguais?" e seguir; a resposta do slide seguinte vale do mesmo jeito.
 Avançar para o slide seguinte com a resposta.</a:t>
             </a:r>
             <a:endParaRPr lang="en-US" dirty="0"/>
@@ -1649,12 +1650,11 @@
           <a:p>
             <a:r>
               <a:rPr lang="en-US" dirty="0"/>
-              <a:t>[25:30–26:45] Slide único, sem cliques: barras e veredito já estão na tela. A: 37,5%, intervalo 18% a 61%. B: 75%, intervalo 51% a 90%. As barras se sobrepõem (51% a 61%): inconclusivo, ou seja, "ainda não dá para saber".
-Analogia: dois candidatos com 37% e 75% parecem distantes, mas, se a pesquisa ouviu só 16 pessoas, as margens de erro se cruzam e ainda é "empate técnico". Mais entrevistas, margem menor.
-O intervalo é a faixa de taxas "verdadeiras" compatíveis com o que vimos, com 95% de confiança. O ponto preto é a taxa observada.
-Wilson em vez da conta "p ± 1,96·√(p(1−p)/n)": com n pequeno ou taxa perto de 0% ou 100%, a conta simples dá intervalo que sai de [0, 1] ou tem largura zero (16/16 daria "100% ± 0"). Wilson não tem esse problema.
-Regra do repo: se o limite inferior de B passa do limite superior de A, "B melhor"; o contrário, "A melhor"; senão, "inconclusivo". Inconclusivo não é empate: é "não tenho dado para dizer".
-Não se sobrepor é um critério conservador de propósito (um teste z de duas proporções chamaria 6/16 × 12/16 de significativo, p≈0,03); o repo prefere não declarar vencedor cedo.</a:t>
+              <a:t>[25:30–26:45] Slide único, sem cliques. Não tem número de propósito: é a regra para ler qualquer relatório, inclusive o de hoje.
+Fala: "Cada variante tem a sua faixa: a margem de erro. Se as faixas se cruzam, ainda não dá para saber quem é melhor. Só quando elas se separam dá para dizer." Depois, apontar para o relatório de hoje (slide 18): "No nosso, as faixas se cruzam. Então: ainda não dá para saber."
+Analogia: pesquisa eleitoral com poucas entrevistas: dois candidatos parecem longe, mas as margens se cruzam e é "empate técnico". Mais entrevistas, margem menor.
+Regra do repo: se a faixa de B fica toda acima da de A, "B melhor"; toda abaixo, "A melhor"; senão, "inconclusivo" (= ainda não dá para saber). Não é empate: é "não tenho dado para dizer".
+Se perguntarem por que não um teste de hipótese: exigir faixas sem cruzar é mais rigoroso de propósito; um teste z de duas proporções declararia vencedor mais cedo. Por que Wilson: com poucas execuções ou taxa perto de 0% ou 100%, a conta simples dá faixas absurdas (16 de 16 daria "100% ± 0").</a:t>
             </a:r>
             <a:endParaRPr lang="en-US" dirty="0"/>
           </a:p>

</xml_diff>